<commit_message>
Add bilingual English speech script and sync speaker notes
Co-Authored-By: Claude Opus 5.5 <noreply@anthropic.com>
Claude-Session: https://claude.ai/code/session_013YsyLfz4xmXFdgDPMh9wtS
</commit_message>
<xml_diff>
--- a/英文部分_English_Part.pptx
+++ b/英文部分_English_Part.pptx
@@ -824,7 +824,7 @@
           <a:lstStyle/>
           <a:p>
             <a:r>
-              <a:t>Thank you. My classmate has answered the three questions in Chinese. In the English part I will not repeat those answers. I will summarise the case, pull out the core problem behind it, and dig deeper with comparative law, legal history and empirical research, always coming back to Sanyou.</a:t>
+              <a:t>Thank you. My classmate has explained the three questions clearly. In the English part, I won't repeat those answers. Instead, I'll first summarise the case, then pull out the core problem behind it, and finally dig deeper — with comparative law, legal history, real data and litigation practice. But I'll always come back to Sanyou.</a:t>
             </a:r>
           </a:p>
         </p:txBody>
@@ -882,7 +882,13 @@
           <a:lstStyle/>
           <a:p>
             <a:r>
-              <a:t>Deep dive four: the breaking point, piercing the veil. Empirically, Chinese courts pierce more readily than Western courts. Huang Hui's empirical study found China's piercing rate well above those abroad, and highest for small closely held companies, exactly like Sanyou. A 2025 study by Cheng found that after the 2023 revision, first-instance courts more than doubled their piercing rate in sister-company cases, from about 18 to about 46 percent. English courts, by contrast, pierce only to stop evasion, as a last resort, after Prest v Petrodel. On the current facts Sanyou would not be pierced. But three twists would change that. If A bought out B and C, Sanyou would become a one-shareholder company and A would have to prove the assets are separate. If Sanyou paid A's personal bills, that is commingling. If A's other company siphoned off Sanyou's business, the new horizontal piercing rule applies. These map onto the subject, conduct and result requirements in our notes.</a:t>
+              <a:t>Condition four: when does the line break? Chinese courts pierce the corporate veil more readily than Western courts. Professor Huang Hui's empirical study found China's piercing rate well above foreign rates — especially for small, closely held companies like Sanyou. A 2025 study by Cheng found that after the 2023 revision, first-instance courts more than doubled their piercing rate in sister-company cases: from about 18 to about 46 percent. English courts, by contrast, pierce only to stop evasion, as a last resort.</a:t>
+            </a:r>
+          </a:p>
+          <a:p/>
+          <a:p>
+            <a:r>
+              <a:t>On the current facts, Sanyou would not be pierced. But three twists would change that. If A bought out B and C, Sanyou would become a one-shareholder company, and A would have to prove its assets are separate. If Sanyou paid A's personal bills, that is mixing of assets. And if A's other company took over Sanyou's business, the new sister-company rule would apply.</a:t>
             </a:r>
           </a:p>
         </p:txBody>
@@ -940,7 +946,7 @@
           <a:lstStyle/>
           <a:p>
             <a:r>
-              <a:t>So, back to the core question: when is it fair for the supplier to bear the loss? Our answer: only when Sanyou's capital is real, meaning fairly valued, actually transferred and paid on time, and when the company is truly separate from its owners. If those conditions fail, the line moves toward the shareholders. It moves a limited distance for capital defects, capped at the shortfall, and without limit for abuse. The liability map on the left shows this from the inside out.</a:t>
+              <a:t>So, back to our core question: when is it fair for the supplier to bear the loss? Our answer: only when Sanyou's capital is real — fairly valued, actually transferred and paid on time — and when the company is truly separate from its owners. If those conditions fail, the line moves toward A, B and C: a limited distance for capital defects, and without limit for abuse.</a:t>
             </a:r>
           </a:p>
         </p:txBody>
@@ -998,7 +1004,7 @@
           <a:lstStyle/>
           <a:p>
             <a:r>
-              <a:t>To close: limited liability is a privilege, not a shield for abuse. It holds only as long as the capital is real and the company is truly separate. Thank you.</a:t>
+              <a:t>To close: limited liability is a privilege, not a shield for abuse. It holds only as long as the capital is real and the company is truly separate.</a:t>
             </a:r>
           </a:p>
         </p:txBody>
@@ -1056,7 +1062,65 @@
           <a:lstStyle/>
           <a:p>
             <a:r>
-              <a:t>Briefly introduce who did what.</a:t>
+              <a:t>Finally, here is how our team divided the work. [Read the names and tasks in the table.]</a:t>
+            </a:r>
+          </a:p>
+        </p:txBody>
+      </p:sp>
+    </p:spTree>
+  </p:cSld>
+  <p:clrMapOvr>
+    <a:masterClrMapping/>
+  </p:clrMapOvr>
+</p:notes>
+</file>
+
+<file path=ppt/notesSlides/notesSlide14.xml><?xml version="1.0" encoding="utf-8"?>
+<p:notes xmlns:a="http://schemas.openxmlformats.org/drawingml/2006/main" xmlns:p="http://schemas.openxmlformats.org/presentationml/2006/main" xmlns:r="http://schemas.openxmlformats.org/officeDocument/2006/relationships">
+  <p:cSld>
+    <p:spTree>
+      <p:nvGrpSpPr>
+        <p:cNvPr id="1" name=""/>
+        <p:cNvGrpSpPr/>
+        <p:nvPr/>
+      </p:nvGrpSpPr>
+      <p:grpSpPr>
+        <a:xfrm>
+          <a:off x="0" y="0"/>
+          <a:ext cx="0" cy="0"/>
+          <a:chOff x="0" y="0"/>
+          <a:chExt cx="0" cy="0"/>
+        </a:xfrm>
+      </p:grpSpPr>
+      <p:sp>
+        <p:nvSpPr>
+          <p:cNvPr id="2" name="Slide Image Placeholder 1"/>
+          <p:cNvSpPr>
+            <a:spLocks noGrp="1"/>
+          </p:cNvSpPr>
+          <p:nvPr>
+            <p:ph type="sldImg" idx="2"/>
+          </p:nvPr>
+        </p:nvSpPr>
+        <p:spPr/>
+      </p:sp>
+      <p:sp>
+        <p:nvSpPr>
+          <p:cNvPr id="3" name="Notes Placeholder 2"/>
+          <p:cNvSpPr>
+            <a:spLocks noGrp="1"/>
+          </p:cNvSpPr>
+          <p:nvPr>
+            <p:ph type="body" idx="1"/>
+          </p:nvPr>
+        </p:nvSpPr>
+        <p:spPr/>
+        <p:txBody>
+          <a:bodyPr/>
+          <a:lstStyle/>
+          <a:p>
+            <a:r>
+              <a:t>Thank you for listening. We're happy to take your questions.</a:t>
             </a:r>
           </a:p>
         </p:txBody>
@@ -1114,7 +1178,7 @@
           <a:lstStyle/>
           <a:p>
             <a:r>
-              <a:t>Let me start with the case text itself, because the wording already contains the legal issues. 'Contributed' and 'invested' describe a capital contribution: the price paid for shares. In common-law language, which we met in class, it is the consideration for the shares. 'Valued at' raises a question: who checked that number? 'Co., Ltd.' is not decoration. As our notes on business names say, the organisational form in a company's name tells the public how its owners are liable. 'Owed a supplier' tells us the creditor is a voluntary, contractual creditor, which will matter later. And when B and C say the assets belong to the company, they are invoking the company's separate property, while the supplier is trying to cross that line.</a:t>
+              <a:t>Let's start with the case text itself, because the words already carry the legal issues. "Contributed" and "invested" describe a capital contribution — the price paid for shares. In common-law terms, which we met in class, it is the consideration for the shares. "Valued at" raises a question: who checked that price? "Co., Ltd." is not decoration. As our notes on business names say, the organisational form in a company's name tells the public how its owners are liable. "Owed a supplier" tells us the creditor is a voluntary, contractual creditor — that will matter later. And when B and C say the assets "already belong to the company", they are relying on the company's separate property, while the supplier is trying to cross that line.</a:t>
             </a:r>
           </a:p>
         </p:txBody>
@@ -1172,7 +1236,7 @@
           <a:lstStyle/>
           <a:p>
             <a:r>
-              <a:t>In one breath, here is what the Chinese part established. Three forms of contribution: cash, intellectual property and property in kind. Once contributed, the patent and the equipment belong to the company, and the company pays first with all of its assets. And generally the court will not let the supplier reach the shareholders' personal assets, because their liability is capped at their subscribed capital. But this short answer hides harder questions. That is where the English part begins.</a:t>
+              <a:t>In one breath, here is what the Chinese part established. Three forms of contribution: cash, intellectual property and property in kind. Once contributed, the patent and equipment belong to the company, which pays first with all of its assets. And generally, the supplier cannot reach the shareholders' personal assets, because their liability is capped at their subscribed capital. But this short answer hides harder questions.</a:t>
             </a:r>
           </a:p>
         </p:txBody>
@@ -1230,7 +1294,7 @@
           <a:lstStyle/>
           <a:p>
             <a:r>
-              <a:t>If we abstract the case, the core is this. Limited liability moves business risk from shareholders to creditors. When Sanyou cannot pay, the supplier, not A, B or C, absorbs the loss. The law accepts this, but only under conditions. So the real question is: under what conditions is that shift fair? I will test four conditions, each through the facts of Sanyou. First, the quality of capital: is B's patent really worth 200,000? Second, the reality of capital: when must the money actually arrive? Third, the creditor's side: why should the supplier bear the loss, and what can it do? Fourth, the breaking point: what facts would let the supplier reach personal assets?</a:t>
+              <a:t>So what is the core of the problem? Limited liability shifts business risk from shareholders to creditors. If Sanyou cannot pay, the supplier — not A, B or C — absorbs the loss. The law accepts this, but only under certain conditions. So the real question is: under what conditions is that shift fair? I'll test four conditions, each through the facts of Sanyou: the quality of capital, the reality of capital, the creditor's side, and the breaking point.</a:t>
             </a:r>
           </a:p>
         </p:txBody>
@@ -1288,7 +1352,13 @@
           <a:lstStyle/>
           <a:p>
             <a:r>
-              <a:t>Deep dive one: the quality of capital. On paper the three contributions add up to 600,000 yuan. But A's cash is certain, while B's patent and C's equipment carry hidden risks. A patent can be declared invalid, and under Article 47 of the Patent Law an invalidated patent is deemed never to have existed. Its 20-year term keeps running down, and it may already be licensed to others. Equipment depreciates, the seller may still hold title, or it may be mortgaged, and encumbered property cannot be contributed at all. So who bears these risks? If the asset was overvalued at the time of contribution, B must make up the gap and A and C are jointly liable within it. If it simply lost value later because of the market, nobody has to top it up. A patent invalidated after contribution is the hard case: since the defect existed from the start, there is a strong argument that B never fully performed. This links to the forms of contribution and the principle of capital determination from our notes.</a:t>
+              <a:t>Condition one: the quality of capital. On paper, the three contributions add up to 600,000 yuan. But not all yuan are equal. A's cash is certain. B's patent and C's equipment carry hidden risks. A patent can be declared invalid — and under Article 47 of the Patent Law, an invalid patent is treated as if it never existed. Its term also keeps running down, and it may already be licensed to others. Equipment depreciates, the seller may still own it, or it may be mortgaged — and mortgaged property cannot be contributed at all.</a:t>
+            </a:r>
+          </a:p>
+          <a:p/>
+          <a:p>
+            <a:r>
+              <a:t>So who bears these risks? If the asset was overvalued at the time of contribution, B must make up the gap, and A and C are jointly liable within it. If it simply lost value later because of the market, no one has to top it up. The hard case is a patent invalidated after contribution: since the defect existed from day one, there is a strong argument that B never properly contributed.</a:t>
             </a:r>
           </a:p>
         </p:txBody>
@@ -1346,7 +1416,13 @@
           <a:lstStyle/>
           <a:p>
             <a:r>
-              <a:t>How do other systems police non-cash capital? In common law, shares must be paid for in money or money's worth. This is the consideration idea from our notes. For a private UK company, courts will not second-guess the price unless it is fraudulent or illusory: that is Re Wragg from 1897. Only public companies need an independent valuation, under section 593 of the Companies Act and the EU company law directive. In Delaware, the directors' judgment of the value is conclusive unless there is actual fraud. China is the strictest: every company must value non-cash contributions, and the founders guarantee each other. So, back to Sanyou: under UK or Delaware law, B's 200,000 valuation would most likely stand. Under Chinese law, a creditor can challenge it years later, and even A, who paid in cash, may be on the hook.</a:t>
+              <a:t>Who checks the price? Other legal systems answer very differently. In common law, shares must be paid for in "money or money's worth" — the consideration idea from our notes. For a private UK company, courts will not question whether the price is adequate unless there is fraud: that is Re Wragg, from 1897. Only public companies need an independent valuation, in the UK and across the EU. In Delaware, the directors' judgment of value is final unless there is actual fraud. China is the strictest: every company must value non-cash contributions, and the founders guarantee each other.</a:t>
+            </a:r>
+          </a:p>
+          <a:p/>
+          <a:p>
+            <a:r>
+              <a:t>Back to Sanyou: in the UK or Delaware, B's 200,000-yuan valuation would most likely stand. In China, a creditor can challenge it years later — and even A, who paid in cash, could be on the hook.</a:t>
             </a:r>
           </a:p>
         </p:txBody>
@@ -1404,7 +1480,13 @@
           <a:lstStyle/>
           <a:p>
             <a:r>
-              <a:t>Deep dive two: the reality of capital. Whether A, B and C still owe anything depends on when Sanyou was formed, because China's capital regime has swung like a pendulum. In 1993 we had a strict legal capital system: minimum capital of 100,000 to 500,000 yuan, fully paid before registration. In 2005 the minimum fell to 30,000, with 20 percent upfront and the rest within two years. In 2013 the law moved to full subscription: no minimum, no deadline. That produced 'paper capital': companies subscribing huge amounts payable in 50 or 100 years. The 2019 Ninth Minutes allowed acceleration only in narrow cases. The 2023 law swung back: five-year payment, acceleration, joint founder liability and forfeiture, and existing companies must adjust by June 2027. For Sanyou: if it was formed after July 2024, all capital is due within five years; if earlier, its deadlines must be brought within that window. This connects to the legal versus authorised capital systems and the three capital principles in our notes.</a:t>
+              <a:t>Condition two: the reality of capital. Whether A, B and C still owe anything depends on when Sanyou was formed, because China's capital rules have swung like a pendulum. In 1993, capital had to be fully paid before registration, with a minimum of 100,000 to 500,000 yuan. In 2005, the minimum fell to 30,000, with 20 percent paid upfront. In 2013, the law moved to full subscription: no minimum and no deadline. That led to "paper capital" — companies promising huge amounts, payable in 50 or even 100 years. In 2019, the Ninth Minutes allowed early payment only in narrow cases. The 2023 law swung back: capital must be paid within five years, creditors can demand early payment, and existing companies must adjust by June 2027.</a:t>
+            </a:r>
+          </a:p>
+          <a:p/>
+          <a:p>
+            <a:r>
+              <a:t>For Sanyou: if it was formed after July 2024, all capital is due within five years. This links to the legal capital and authorised capital systems in our notes.</a:t>
             </a:r>
           </a:p>
         </p:txBody>
@@ -1462,7 +1544,13 @@
           <a:lstStyle/>
           <a:p>
             <a:r>
-              <a:t>Deep dive three looks at the creditor's side, first in practice. If I were the supplier's lawyer, this is the sequence. One: sue Sanyou and get a judgment. Two: enforce against the company's assets, which include the patent and the equipment. Three: if there is a shortfall, either add the shareholders who have not paid as judgment debtors in the enforcement proceedings, under Article 17 of the Supreme People's Court enforcement provisions, or sue them for supplementary liability under Interpretation Three. Courts generally only allow the enforcement route where the contribution is already due. Four: if it is not yet due, demand acceleration under Article 54. Five: if there is abuse, seek piercing under Article 23. Two details are worth knowing. Shareholders cannot use the limitation period as a defence against contribution claims. And there is an open debate: under Article 54, does the accelerated money go into the company for all creditors, or straight to the creditor who sued?</a:t>
+              <a:t>Condition three looks at the creditor's side — first in practice. If I were the supplier's lawyer, this is my plan. Step one: sue Sanyou and get a judgment. Step two: enforce it against the company's assets, including the patent and equipment. Step three: if that is not enough, add the shareholders who have not paid as judgment debtors, or sue them for the unpaid amount. Step four: if their payment deadline has not arrived, demand early payment under Article 54. Step five: only if there is abuse, ask the court to pierce the veil.</a:t>
+            </a:r>
+          </a:p>
+          <a:p/>
+          <a:p>
+            <a:r>
+              <a:t>Two details. Shareholders cannot escape by saying the claim is out of time. And there is an open debate: under Article 54, does the early payment go into the company for all creditors, or straight to the creditor who sued?</a:t>
             </a:r>
           </a:p>
         </p:txBody>
@@ -1520,7 +1608,13 @@
           <a:lstStyle/>
           <a:p>
             <a:r>
-              <a:t>Now the theory. Why should the supplier carry the loss? Easterbrook and Fischel's classic answer is that limited liability encourages investment, allows diversification and lowers monitoring costs. But Hansmann and Kraakman point out that this works for voluntary creditors, who can bargain, and is much harder to justify for involuntary creditors such as tort victims. The supplier is a voluntary creditor. It could have protected itself: Article 40 of the Company Law requires companies to publish each shareholder's subscribed and paid-in capital, method and dates on the national credit information system. It could have asked A, B and C for a personal guarantee, or kept title to its goods until paid under Article 641 of the Civil Code. In short, the law protects creditors who protect themselves. This reflects the two functions of commercial law in our notes: speed of transactions and security of transactions, supported by registration and publicity.</a:t>
+              <a:t>But why should the supplier bear the loss at all? Easterbrook and Fischel's classic answer: limited liability encourages investment and lets investors diversify. Hansmann and Kraakman add an important point: this is fair for voluntary creditors who can bargain, but hard to justify for victims of accidents, who never chose the company.</a:t>
+            </a:r>
+          </a:p>
+          <a:p/>
+          <a:p>
+            <a:r>
+              <a:t>Our supplier is a voluntary creditor. It could have protected itself. Under Article 40, every company must publish its shareholders' subscribed and paid-in capital online. The supplier could have asked A, B and C for a personal guarantee, or kept ownership of its goods until paid. In short: the law protects creditors who protect themselves. This reflects the balance in our notes between fast transactions and safe transactions.</a:t>
             </a:r>
           </a:p>
         </p:txBody>

</xml_diff>